<commit_message>
Put product-first growth before ad revenue.
Keeps the 25-slide Shipaton deck and the three growth groups, and says checkout is not the same as ads.
</commit_message>
<xml_diff>
--- a/talks/whats-stopping-us-from-building-great-products-and-monetizing-them/whats-stopping-us-from-building-great-products-and-monetizing-them.pptx
+++ b/talks/whats-stopping-us-from-building-great-products-and-monetizing-them/whats-stopping-us-from-building-great-products-and-monetizing-them.pptx
@@ -921,12 +921,17 @@
           <a:lstStyle/>
           <a:p>
             <a:r>
-              <a:t>Tanglish: Growth team-oda velai-nu theriyum. AI era-la neenga pick up panna mudiyum.</a:t>
+              <a:t>Tanglish: Growth team-oda velai-nu theriyum. AI era-la neenga pick up panna mudiyum. First product-ah valarunga. Use pannanavanga irukanum. Appuram ads.</a:t>
             </a:r>
           </a:p>
           <a:p>
             <a:r>
               <a:t>These used to look like a growth team's job. In the AI era you can pick them up.</a:t>
+            </a:r>
+          </a:p>
+          <a:p>
+            <a:r>
+              <a:t>Grow the product first. Then revenue, like ads. When the topic is making money from the product, people have to be using it before ads. Do not skip the earlier payment slides. Customer checkout and ad revenue are different.</a:t>
             </a:r>
           </a:p>
           <a:p>
@@ -7511,7 +7516,7 @@
         </p:nvSpPr>
         <p:spPr>
           <a:xfrm>
-            <a:off x="640080" y="411480"/>
+            <a:off x="640080" y="256032"/>
             <a:ext cx="10881360" cy="1737360"/>
           </a:xfrm>
           <a:prstGeom prst="rect">
@@ -7527,7 +7532,7 @@
           <a:p>
             <a:pPr algn="ctr"/>
             <a:r>
-              <a:rPr sz="3000" b="1">
+              <a:rPr sz="2800" b="1">
                 <a:solidFill>
                   <a:srgbClr val="1D1D1F"/>
                 </a:solidFill>
@@ -7546,7 +7551,7 @@
         </p:nvSpPr>
         <p:spPr>
           <a:xfrm>
-            <a:off x="640080" y="2194560"/>
+            <a:off x="640080" y="2039112"/>
             <a:ext cx="10881360" cy="777240"/>
           </a:xfrm>
           <a:prstGeom prst="rect">
@@ -7575,14 +7580,49 @@
       </p:sp>
       <p:sp>
         <p:nvSpPr>
-          <p:cNvPr id="5" name="Rounded Rectangle 4"/>
+          <p:cNvPr id="5" name="TextBox 4"/>
+          <p:cNvSpPr txBox="1"/>
+          <p:nvPr/>
+        </p:nvSpPr>
+        <p:spPr>
+          <a:xfrm>
+            <a:off x="640080" y="2697480"/>
+            <a:ext cx="10881360" cy="502920"/>
+          </a:xfrm>
+          <a:prstGeom prst="rect">
+            <a:avLst/>
+          </a:prstGeom>
+          <a:noFill/>
+        </p:spPr>
+        <p:txBody>
+          <a:bodyPr wrap="square">
+            <a:spAutoFit/>
+          </a:bodyPr>
+          <a:lstStyle/>
+          <a:p>
+            <a:pPr algn="ctr"/>
+            <a:r>
+              <a:rPr sz="2000" b="1">
+                <a:solidFill>
+                  <a:srgbClr val="1D1D1F"/>
+                </a:solidFill>
+                <a:latin typeface="Calibri"/>
+              </a:rPr>
+              <a:t>Grow the product first. Then revenue, like ads.</a:t>
+            </a:r>
+          </a:p>
+        </p:txBody>
+      </p:sp>
+      <p:sp>
+        <p:nvSpPr>
+          <p:cNvPr id="6" name="Rounded Rectangle 5"/>
           <p:cNvSpPr/>
           <p:nvPr/>
         </p:nvSpPr>
         <p:spPr>
           <a:xfrm>
-            <a:off x="1025499" y="3063240"/>
-            <a:ext cx="3246120" cy="2148840"/>
+            <a:off x="1025499" y="3383280"/>
+            <a:ext cx="3246120" cy="2011680"/>
           </a:xfrm>
           <a:prstGeom prst="roundRect">
             <a:avLst/>
@@ -7618,13 +7658,13 @@
       </p:sp>
       <p:sp>
         <p:nvSpPr>
-          <p:cNvPr id="6" name="TextBox 5"/>
+          <p:cNvPr id="7" name="TextBox 6"/>
           <p:cNvSpPr txBox="1"/>
           <p:nvPr/>
         </p:nvSpPr>
         <p:spPr>
           <a:xfrm>
-            <a:off x="1162659" y="3319272"/>
+            <a:off x="1162659" y="3639312"/>
             <a:ext cx="2971800" cy="411480"/>
           </a:xfrm>
           <a:prstGeom prst="rect">
@@ -7653,13 +7693,13 @@
       </p:sp>
       <p:sp>
         <p:nvSpPr>
-          <p:cNvPr id="7" name="TextBox 6"/>
+          <p:cNvPr id="8" name="TextBox 7"/>
           <p:cNvSpPr txBox="1"/>
           <p:nvPr/>
         </p:nvSpPr>
         <p:spPr>
           <a:xfrm>
-            <a:off x="1190091" y="3840480"/>
+            <a:off x="1190091" y="4160520"/>
             <a:ext cx="2916936" cy="1143000"/>
           </a:xfrm>
           <a:prstGeom prst="rect">
@@ -7688,14 +7728,14 @@
       </p:sp>
       <p:sp>
         <p:nvSpPr>
-          <p:cNvPr id="8" name="Rounded Rectangle 7"/>
+          <p:cNvPr id="9" name="Rounded Rectangle 8"/>
           <p:cNvSpPr/>
           <p:nvPr/>
         </p:nvSpPr>
         <p:spPr>
           <a:xfrm>
-            <a:off x="4472787" y="3063240"/>
-            <a:ext cx="3246120" cy="2148840"/>
+            <a:off x="4472787" y="3383280"/>
+            <a:ext cx="3246120" cy="2011680"/>
           </a:xfrm>
           <a:prstGeom prst="roundRect">
             <a:avLst/>
@@ -7731,13 +7771,13 @@
       </p:sp>
       <p:sp>
         <p:nvSpPr>
-          <p:cNvPr id="9" name="TextBox 8"/>
+          <p:cNvPr id="10" name="TextBox 9"/>
           <p:cNvSpPr txBox="1"/>
           <p:nvPr/>
         </p:nvSpPr>
         <p:spPr>
           <a:xfrm>
-            <a:off x="4609947" y="3319272"/>
+            <a:off x="4609947" y="3639312"/>
             <a:ext cx="2971800" cy="411480"/>
           </a:xfrm>
           <a:prstGeom prst="rect">
@@ -7766,13 +7806,13 @@
       </p:sp>
       <p:sp>
         <p:nvSpPr>
-          <p:cNvPr id="10" name="TextBox 9"/>
+          <p:cNvPr id="11" name="TextBox 10"/>
           <p:cNvSpPr txBox="1"/>
           <p:nvPr/>
         </p:nvSpPr>
         <p:spPr>
           <a:xfrm>
-            <a:off x="4637379" y="3840480"/>
+            <a:off x="4637379" y="4160520"/>
             <a:ext cx="2916936" cy="1143000"/>
           </a:xfrm>
           <a:prstGeom prst="rect">
@@ -7801,14 +7841,14 @@
       </p:sp>
       <p:sp>
         <p:nvSpPr>
-          <p:cNvPr id="11" name="Rounded Rectangle 10"/>
+          <p:cNvPr id="12" name="Rounded Rectangle 11"/>
           <p:cNvSpPr/>
           <p:nvPr/>
         </p:nvSpPr>
         <p:spPr>
           <a:xfrm>
-            <a:off x="7920075" y="3063240"/>
-            <a:ext cx="3246120" cy="2148840"/>
+            <a:off x="7920075" y="3383280"/>
+            <a:ext cx="3246120" cy="2011680"/>
           </a:xfrm>
           <a:prstGeom prst="roundRect">
             <a:avLst/>
@@ -7844,13 +7884,13 @@
       </p:sp>
       <p:sp>
         <p:nvSpPr>
-          <p:cNvPr id="12" name="TextBox 11"/>
+          <p:cNvPr id="13" name="TextBox 12"/>
           <p:cNvSpPr txBox="1"/>
           <p:nvPr/>
         </p:nvSpPr>
         <p:spPr>
           <a:xfrm>
-            <a:off x="8057235" y="3319272"/>
+            <a:off x="8057235" y="3639312"/>
             <a:ext cx="2971800" cy="411480"/>
           </a:xfrm>
           <a:prstGeom prst="rect">
@@ -7879,13 +7919,13 @@
       </p:sp>
       <p:sp>
         <p:nvSpPr>
-          <p:cNvPr id="13" name="TextBox 12"/>
+          <p:cNvPr id="14" name="TextBox 13"/>
           <p:cNvSpPr txBox="1"/>
           <p:nvPr/>
         </p:nvSpPr>
         <p:spPr>
           <a:xfrm>
-            <a:off x="8084667" y="3840480"/>
+            <a:off x="8084667" y="4160520"/>
             <a:ext cx="2916936" cy="1143000"/>
           </a:xfrm>
           <a:prstGeom prst="rect">

</xml_diff>

<commit_message>
Close the Shipaton deck at twenty-seven slides.
Checkout now says pick one. Startup School sits before the sheet. The DroidCon card and volunteer QR come before Jobs.
</commit_message>
<xml_diff>
--- a/talks/whats-stopping-us-from-building-great-products-and-monetizing-them/whats-stopping-us-from-building-great-products-and-monetizing-them.pptx
+++ b/talks/whats-stopping-us-from-building-great-products-and-monetizing-them/whats-stopping-us-from-building-great-products-and-monetizing-them.pptx
@@ -30,6 +30,8 @@
     <p:sldId id="278" r:id="rId29"/>
     <p:sldId id="279" r:id="rId30"/>
     <p:sldId id="280" r:id="rId31"/>
+    <p:sldId id="281" r:id="rId32"/>
+    <p:sldId id="282" r:id="rId33"/>
   </p:sldIdLst>
   <p:sldSz cx="12191695" cy="6858000" type="screen4x3"/>
   <p:notesSz cx="6858000" cy="9144000"/>
@@ -606,7 +608,12 @@
           <a:lstStyle/>
           <a:p>
             <a:r>
-              <a:t>Tanglish: Checkout-ku anju peru. Ella provider-um venam.</a:t>
+              <a:t>Tanglish: Oruthan pick pannunga. Anju-um venam. Next slide-la oru price, andha checkout.</a:t>
+            </a:r>
+          </a:p>
+          <a:p>
+            <a:r>
+              <a:t>Pick one of these. You do not need all five. Another allowed checkout is fine. The next slide is one price and that checkout.</a:t>
             </a:r>
           </a:p>
           <a:p>
@@ -621,7 +628,7 @@
           </a:p>
           <a:p>
             <a:r>
-              <a:t>RevenueCat is mobile subscriptions. https://www.revenuecat.com/</a:t>
+              <a:t>RevenueCat is mobile subscriptions and stays optional. https://www.revenuecat.com/</a:t>
             </a:r>
           </a:p>
           <a:p>
@@ -632,11 +639,6 @@
           <a:p>
             <a:r>
               <a:t>Apple Pay: wallet checkout where Apple Pay is available. https://developer.apple.com/apple-pay/</a:t>
-            </a:r>
-          </a:p>
-          <a:p>
-            <a:r>
-              <a:t>None of the five is required.</a:t>
             </a:r>
           </a:p>
           <a:p>
@@ -1476,22 +1478,17 @@
           <a:lstStyle/>
           <a:p>
             <a:r>
-              <a:t>Tanglish: Sheet-la fill pannunga. Review Ready-ku maathunga. Organizers dhaan paathu review pannuvaanga.</a:t>
-            </a:r>
-          </a:p>
-          <a:p>
-            <a:r>
-              <a:t>Sheet: https://docs.google.com/spreadsheets/d/1DZ7OSphlY8llxWisVc_FcLGeu9Psj_fvfxR2F7ohxcM/edit?usp=sharing</a:t>
-            </a:r>
-          </a:p>
-          <a:p>
-            <a:r>
-              <a:t>Columns: Product Name, Creator / Team, Product Category, Demo / Product URL, Repository URL, Monetization Model, Payment Integration, Deployment Status, Review Status, Production Ready by Thursday, Notes.</a:t>
-            </a:r>
-          </a:p>
-          <a:p>
-            <a:r>
-              <a:t>Workflow: fill the sheet, update URLs, the participant sets Review Status to Review Ready, organizers review. Review Ready is not approval.</a:t>
+              <a:t>Tanglish: Startup School free. Online. YC. Early lessons-ah use pannunga. Lesson number invent pannaathinga.</a:t>
+            </a:r>
+          </a:p>
+          <a:p>
+            <a:r>
+              <a:t>The QR lives only here. Take Y Combinator Startup School. Free. Online. Say early lessons. Do not invent a lesson number.</a:t>
+            </a:r>
+          </a:p>
+          <a:p>
+            <a:r>
+              <a:t>https://www.startupschool.org/</a:t>
             </a:r>
           </a:p>
         </p:txBody>
@@ -1646,37 +1643,22 @@
           <a:lstStyle/>
           <a:p>
             <a:r>
-              <a:t>Tanglish: Thursday-kku live aaganum. Review Ready-na ‘paathu videoonga.’ Production Ready-na users use panna ready.</a:t>
-            </a:r>
-          </a:p>
-          <a:p>
-            <a:r>
-              <a:t>Say Thursday. Do not print a calendar date.</a:t>
-            </a:r>
-          </a:p>
-          <a:p>
-            <a:r>
-              <a:t>Production Ready by Thursday = deployed and usable. Review Ready = please review.</a:t>
-            </a:r>
-          </a:p>
-          <a:p>
-            <a:r>
-              <a:t>Checklist: production URL; core flow works; usable onboarding; no critical blockers; a clear way to charge; payment flow works when they charge; basic analytics or feedback; enough for organizers to test.</a:t>
-            </a:r>
-          </a:p>
-          <a:p>
-            <a:r>
-              <a:t>Extra DevFest prize eligibility, not an automatic win.</a:t>
-            </a:r>
-          </a:p>
-          <a:p>
-            <a:r>
-              <a:t>https://luma.com/mprx0ocg</a:t>
-            </a:r>
-          </a:p>
-          <a:p>
-            <a:r>
-              <a:t>https://devfest.gdgchennai.in/</a:t>
+              <a:t>Tanglish: Sheet-la fill pannunga. Review Ready-ku maathunga. Organizers dhaan paathu review pannuvaanga.</a:t>
+            </a:r>
+          </a:p>
+          <a:p>
+            <a:r>
+              <a:t>Sheet: https://docs.google.com/spreadsheets/d/1DZ7OSphlY8llxWisVc_FcLGeu9Psj_fvfxR2F7ohxcM/edit?usp=sharing</a:t>
+            </a:r>
+          </a:p>
+          <a:p>
+            <a:r>
+              <a:t>Columns: Product Name, Creator / Team, Product Category, Demo / Product URL, Repository URL, Monetization Model, Payment Integration, Deployment Status, Review Status, Production Ready by Thursday, Notes.</a:t>
+            </a:r>
+          </a:p>
+          <a:p>
+            <a:r>
+              <a:t>Workflow: fill the sheet, update URLs, the participant sets Review Status to Review Ready, organizers review. Review Ready is not approval.</a:t>
             </a:r>
           </a:p>
         </p:txBody>
@@ -1746,32 +1728,32 @@
           <a:lstStyle/>
           <a:p>
             <a:r>
-              <a:t>Tanglish: Ship pannunga. Review aaganum. Ticket-na bonus — guarantee illa.</a:t>
-            </a:r>
-          </a:p>
-          <a:p>
-            <a:r>
-              <a:t>On the slide, attributed to Sam Altman: We're going to see 10 person billion-dollar companies pretty soon.</a:t>
-            </a:r>
-          </a:p>
-          <a:p>
-            <a:r>
-              <a:t>Fuller reported line: We're going to see 10-person companies with billion-dollar valuations pretty soon.</a:t>
-            </a:r>
-          </a:p>
-          <a:p>
-            <a:r>
-              <a:t>https://www.forbes.com/sites/michaelashley/2025/02/17/the-future-is-solo-ai-is-creating-billion-dollar-one-person-companies/</a:t>
-            </a:r>
-          </a:p>
-          <a:p>
-            <a:r>
-              <a:t>Organizers review. Selected winners get DevFest Chennai tickets. Prizes also at DevFest, Sat 17 Oct 2026, IITM Research Park. Thursday production-ready teams are considered for an additional prize — not a guarantee.</a:t>
-            </a:r>
-          </a:p>
-          <a:p>
-            <a:r>
-              <a:t>Judging themes only: usefulness, execution, UX, monetization potential, real deployment, learning. Do not invent amounts, winner counts, or weights.</a:t>
+              <a:t>Tanglish: Thursday-kku live aaganum. Review Ready-na ‘paathu videoonga.’ Production Ready-na users use panna ready.</a:t>
+            </a:r>
+          </a:p>
+          <a:p>
+            <a:r>
+              <a:t>Say Thursday. Do not print a calendar date.</a:t>
+            </a:r>
+          </a:p>
+          <a:p>
+            <a:r>
+              <a:t>Production Ready by Thursday = deployed and usable. Review Ready = please review.</a:t>
+            </a:r>
+          </a:p>
+          <a:p>
+            <a:r>
+              <a:t>Checklist: production URL; core flow works; usable onboarding; no critical blockers; a clear way to charge; payment flow works when they charge; basic analytics or feedback; enough for organizers to test.</a:t>
+            </a:r>
+          </a:p>
+          <a:p>
+            <a:r>
+              <a:t>Extra DevFest prize eligibility, not an automatic win.</a:t>
+            </a:r>
+          </a:p>
+          <a:p>
+            <a:r>
+              <a:t>https://luma.com/mprx0ocg</a:t>
             </a:r>
           </a:p>
           <a:p>
@@ -1846,27 +1828,37 @@
           <a:lstStyle/>
           <a:p>
             <a:r>
-              <a:t>Tanglish: Ippo ivathai follow pannunga. Overwhelm aagadheenga.</a:t>
-            </a:r>
-          </a:p>
-          <a:p>
-            <a:r>
-              <a:t>Three names only. X is build in public. https://x.com/</a:t>
-            </a:r>
-          </a:p>
-          <a:p>
-            <a:r>
-              <a:t>Product Hunt is where new products show up. https://www.producthunt.com/</a:t>
-            </a:r>
-          </a:p>
-          <a:p>
-            <a:r>
-              <a:t>Startup School is the free YC course on the next slide. https://www.startupschool.org/</a:t>
-            </a:r>
-          </a:p>
-          <a:p>
-            <a:r>
-              <a:t>No second QR here. No extra networks.</a:t>
+              <a:t>Tanglish: Ship pannunga. Review aaganum. Ticket-na bonus — guarantee illa.</a:t>
+            </a:r>
+          </a:p>
+          <a:p>
+            <a:r>
+              <a:t>On the slide, attributed to Sam Altman: We're going to see 10 person billion-dollar companies pretty soon.</a:t>
+            </a:r>
+          </a:p>
+          <a:p>
+            <a:r>
+              <a:t>Fuller reported line: We're going to see 10-person companies with billion-dollar valuations pretty soon.</a:t>
+            </a:r>
+          </a:p>
+          <a:p>
+            <a:r>
+              <a:t>https://www.forbes.com/sites/michaelashley/2025/02/17/the-future-is-solo-ai-is-creating-billion-dollar-one-person-companies/</a:t>
+            </a:r>
+          </a:p>
+          <a:p>
+            <a:r>
+              <a:t>Organizers review. Selected winners get DevFest Chennai tickets. Prizes also at DevFest, Sat 17 Oct 2026, IITM Research Park. Thursday production-ready teams are considered for an additional prize — not a guarantee.</a:t>
+            </a:r>
+          </a:p>
+          <a:p>
+            <a:r>
+              <a:t>Judging themes only: usefulness, execution, UX, monetization potential, real deployment, learning. Do not invent amounts, winner counts, or weights.</a:t>
+            </a:r>
+          </a:p>
+          <a:p>
+            <a:r>
+              <a:t>https://devfest.gdgchennai.in/</a:t>
             </a:r>
           </a:p>
         </p:txBody>
@@ -1936,17 +1928,27 @@
           <a:lstStyle/>
           <a:p>
             <a:r>
-              <a:t>Tanglish: Startup School free. Online. YC. Early lessons-ah use pannunga. Lesson number invent pannaathinga.</a:t>
-            </a:r>
-          </a:p>
-          <a:p>
-            <a:r>
-              <a:t>The QR lives only here. The previous slide only named Startup School as something to follow. Take Y Combinator Startup School. Free. Online. Say early lessons. Do not invent a lesson number.</a:t>
-            </a:r>
-          </a:p>
-          <a:p>
-            <a:r>
-              <a:t>https://www.startupschool.org/</a:t>
+              <a:t>Tanglish: Ippo ivathai follow pannunga. Overwhelm aagadheenga.</a:t>
+            </a:r>
+          </a:p>
+          <a:p>
+            <a:r>
+              <a:t>Three names only. X is build in public. https://x.com/</a:t>
+            </a:r>
+          </a:p>
+          <a:p>
+            <a:r>
+              <a:t>Product Hunt is where new products show up. https://www.producthunt.com/</a:t>
+            </a:r>
+          </a:p>
+          <a:p>
+            <a:r>
+              <a:t>Startup School is the free YC course shown earlier. https://www.startupschool.org/</a:t>
+            </a:r>
+          </a:p>
+          <a:p>
+            <a:r>
+              <a:t>No second QR here. No extra networks.</a:t>
             </a:r>
           </a:p>
         </p:txBody>
@@ -2052,6 +2054,171 @@
 </file>
 
 <file path=ppt/notesSlides/notesSlide25.xml><?xml version="1.0" encoding="utf-8"?>
+<p:notes xmlns:a="http://schemas.openxmlformats.org/drawingml/2006/main" xmlns:p="http://schemas.openxmlformats.org/presentationml/2006/main" xmlns:r="http://schemas.openxmlformats.org/officeDocument/2006/relationships">
+  <p:cSld>
+    <p:spTree>
+      <p:nvGrpSpPr>
+        <p:cNvPr id="1" name=""/>
+        <p:cNvGrpSpPr/>
+        <p:nvPr/>
+      </p:nvGrpSpPr>
+      <p:grpSpPr>
+        <a:xfrm>
+          <a:off x="0" y="0"/>
+          <a:ext cx="0" cy="0"/>
+          <a:chOff x="0" y="0"/>
+          <a:chExt cx="0" cy="0"/>
+        </a:xfrm>
+      </p:grpSpPr>
+      <p:sp>
+        <p:nvSpPr>
+          <p:cNvPr id="2" name="Slide Image Placeholder 1"/>
+          <p:cNvSpPr>
+            <a:spLocks noGrp="1"/>
+          </p:cNvSpPr>
+          <p:nvPr>
+            <p:ph type="sldImg" idx="2"/>
+          </p:nvPr>
+        </p:nvSpPr>
+        <p:spPr/>
+      </p:sp>
+      <p:sp>
+        <p:nvSpPr>
+          <p:cNvPr id="3" name="Notes Placeholder 2"/>
+          <p:cNvSpPr>
+            <a:spLocks noGrp="1"/>
+          </p:cNvSpPr>
+          <p:nvPr>
+            <p:ph type="body" idx="3" sz="quarter"/>
+          </p:nvPr>
+        </p:nvSpPr>
+        <p:spPr/>
+        <p:txBody>
+          <a:bodyPr/>
+          <a:lstStyle/>
+          <a:p>
+            <a:r>
+              <a:t>Tanglish: Indha card-ah vechi vidunga. Title overlay pannaathinga.</a:t>
+            </a:r>
+          </a:p>
+          <a:p>
+            <a:r>
+              <a:t>Whole image. No crop. No title on the slide. The date stays inside the art. 20% off, code KUGCHENNAI, 20 Nov 2026, Bengaluru — that is on the card, not a second headline.</a:t>
+            </a:r>
+          </a:p>
+          <a:p>
+            <a:r>
+              <a:t>https://india.droidcon.com/</a:t>
+            </a:r>
+          </a:p>
+          <a:p>
+            <a:r>
+              <a:t>https://ibb.co/3mpLSXFq</a:t>
+            </a:r>
+          </a:p>
+        </p:txBody>
+      </p:sp>
+      <p:sp>
+        <p:nvSpPr>
+          <p:cNvPr id="4" name="Slide Number Placeholder 3"/>
+          <p:cNvSpPr>
+            <a:spLocks noGrp="1"/>
+          </p:cNvSpPr>
+          <p:nvPr>
+            <p:ph type="sldNum" idx="5" sz="quarter"/>
+          </p:nvPr>
+        </p:nvSpPr>
+        <p:spPr/>
+      </p:sp>
+    </p:spTree>
+  </p:cSld>
+  <p:clrMapOvr>
+    <a:masterClrMapping/>
+  </p:clrMapOvr>
+</p:notes>
+</file>
+
+<file path=ppt/notesSlides/notesSlide26.xml><?xml version="1.0" encoding="utf-8"?>
+<p:notes xmlns:a="http://schemas.openxmlformats.org/drawingml/2006/main" xmlns:p="http://schemas.openxmlformats.org/presentationml/2006/main" xmlns:r="http://schemas.openxmlformats.org/officeDocument/2006/relationships">
+  <p:cSld>
+    <p:spTree>
+      <p:nvGrpSpPr>
+        <p:cNvPr id="1" name=""/>
+        <p:cNvGrpSpPr/>
+        <p:nvPr/>
+      </p:nvGrpSpPr>
+      <p:grpSpPr>
+        <a:xfrm>
+          <a:off x="0" y="0"/>
+          <a:ext cx="0" cy="0"/>
+          <a:chOff x="0" y="0"/>
+          <a:chExt cx="0" cy="0"/>
+        </a:xfrm>
+      </p:grpSpPr>
+      <p:sp>
+        <p:nvSpPr>
+          <p:cNvPr id="2" name="Slide Image Placeholder 1"/>
+          <p:cNvSpPr>
+            <a:spLocks noGrp="1"/>
+          </p:cNvSpPr>
+          <p:nvPr>
+            <p:ph type="sldImg" idx="2"/>
+          </p:nvPr>
+        </p:nvSpPr>
+        <p:spPr/>
+      </p:sp>
+      <p:sp>
+        <p:nvSpPr>
+          <p:cNvPr id="3" name="Notes Placeholder 2"/>
+          <p:cNvSpPr>
+            <a:spLocks noGrp="1"/>
+          </p:cNvSpPr>
+          <p:nvPr>
+            <p:ph type="body" idx="3" sz="quarter"/>
+          </p:nvPr>
+        </p:nvSpPr>
+        <p:spPr/>
+        <p:txBody>
+          <a:bodyPr/>
+          <a:lstStyle/>
+          <a:p>
+            <a:r>
+              <a:t>Tanglish: Volunteer aaganum-na scan pannunga. Form fill pannunga.</a:t>
+            </a:r>
+          </a:p>
+          <a:p>
+            <a:r>
+              <a:t>This is the last slide before Jobs. Large QR. It decodes to https://forms.gle/bpL3rYXffdDWCMK89</a:t>
+            </a:r>
+          </a:p>
+          <a:p>
+            <a:r>
+              <a:t>Leave the form title up. Do not invent extra volunteer perks.</a:t>
+            </a:r>
+          </a:p>
+        </p:txBody>
+      </p:sp>
+      <p:sp>
+        <p:nvSpPr>
+          <p:cNvPr id="4" name="Slide Number Placeholder 3"/>
+          <p:cNvSpPr>
+            <a:spLocks noGrp="1"/>
+          </p:cNvSpPr>
+          <p:nvPr>
+            <p:ph type="sldNum" idx="5" sz="quarter"/>
+          </p:nvPr>
+        </p:nvSpPr>
+        <p:spPr/>
+      </p:sp>
+    </p:spTree>
+  </p:cSld>
+  <p:clrMapOvr>
+    <a:masterClrMapping/>
+  </p:clrMapOvr>
+</p:notes>
+</file>
+
+<file path=ppt/notesSlides/notesSlide27.xml><?xml version="1.0" encoding="utf-8"?>
 <p:notes xmlns:a="http://schemas.openxmlformats.org/drawingml/2006/main" xmlns:p="http://schemas.openxmlformats.org/presentationml/2006/main" xmlns:r="http://schemas.openxmlformats.org/officeDocument/2006/relationships">
   <p:cSld>
     <p:spTree>
@@ -5890,7 +6057,7 @@
                 </a:solidFill>
                 <a:latin typeface="Calibri"/>
               </a:rPr>
-              <a:t>Pick a checkout.</a:t>
+              <a:t>Pick one.</a:t>
             </a:r>
           </a:p>
         </p:txBody>
@@ -5925,7 +6092,7 @@
                 </a:solidFill>
                 <a:latin typeface="Calibri"/>
               </a:rPr>
-              <a:t>None of these is required.</a:t>
+              <a:t>Any of these is fine.</a:t>
             </a:r>
           </a:p>
         </p:txBody>
@@ -9750,7 +9917,7 @@
         <p:spPr>
           <a:xfrm>
             <a:off x="640080" y="640080"/>
-            <a:ext cx="10881360" cy="1143000"/>
+            <a:ext cx="10881360" cy="1051560"/>
           </a:xfrm>
           <a:prstGeom prst="rect">
             <a:avLst/>
@@ -9765,20 +9932,55 @@
           <a:p>
             <a:pPr algn="ctr"/>
             <a:r>
-              <a:rPr sz="3400" b="1">
+              <a:rPr sz="3600" b="1">
                 <a:solidFill>
                   <a:srgbClr val="1D1D1F"/>
                 </a:solidFill>
                 <a:latin typeface="Calibri"/>
               </a:rPr>
-              <a:t>One sheet. Set Review Ready.</a:t>
+              <a:t>Take Startup School.</a:t>
+            </a:r>
+          </a:p>
+        </p:txBody>
+      </p:sp>
+      <p:sp>
+        <p:nvSpPr>
+          <p:cNvPr id="4" name="TextBox 3"/>
+          <p:cNvSpPr txBox="1"/>
+          <p:nvPr/>
+        </p:nvSpPr>
+        <p:spPr>
+          <a:xfrm>
+            <a:off x="640080" y="1737360"/>
+            <a:ext cx="10881360" cy="502920"/>
+          </a:xfrm>
+          <a:prstGeom prst="rect">
+            <a:avLst/>
+          </a:prstGeom>
+          <a:noFill/>
+        </p:spPr>
+        <p:txBody>
+          <a:bodyPr wrap="square">
+            <a:spAutoFit/>
+          </a:bodyPr>
+          <a:lstStyle/>
+          <a:p>
+            <a:pPr algn="ctr"/>
+            <a:r>
+              <a:rPr sz="2200" b="0">
+                <a:solidFill>
+                  <a:srgbClr val="6E6E73"/>
+                </a:solidFill>
+                <a:latin typeface="Calibri"/>
+              </a:rPr>
+              <a:t>Free. Online. From YC.</a:t>
             </a:r>
           </a:p>
         </p:txBody>
       </p:sp>
       <p:pic>
         <p:nvPicPr>
-          <p:cNvPr id="4" name="Picture 3" descr="shipaton-sheet-qr.png"/>
+          <p:cNvPr id="5" name="Picture 4" descr="startup-school-qr.png"/>
           <p:cNvPicPr>
             <a:picLocks noChangeAspect="1"/>
           </p:cNvPicPr>
@@ -9792,7 +9994,7 @@
         </p:blipFill>
         <p:spPr>
           <a:xfrm>
-            <a:off x="4160520" y="1965960"/>
+            <a:off x="4160520" y="2331720"/>
             <a:ext cx="3840480" cy="3840480"/>
           </a:xfrm>
           <a:prstGeom prst="rect">
@@ -10078,8 +10280,8 @@
         </p:nvSpPr>
         <p:spPr>
           <a:xfrm>
-            <a:off x="640080" y="1874519"/>
-            <a:ext cx="10881360" cy="1737360"/>
+            <a:off x="640080" y="640080"/>
+            <a:ext cx="10881360" cy="1143000"/>
           </a:xfrm>
           <a:prstGeom prst="rect">
             <a:avLst/>
@@ -10094,251 +10296,41 @@
           <a:p>
             <a:pPr algn="ctr"/>
             <a:r>
-              <a:rPr sz="4000" b="1">
+              <a:rPr sz="3400" b="1">
                 <a:solidFill>
                   <a:srgbClr val="1D1D1F"/>
                 </a:solidFill>
                 <a:latin typeface="Calibri"/>
               </a:rPr>
-              <a:t>Thursday. Make it live.</a:t>
-            </a:r>
-          </a:p>
-        </p:txBody>
-      </p:sp>
-      <p:sp>
-        <p:nvSpPr>
-          <p:cNvPr id="4" name="Rounded Rectangle 3"/>
-          <p:cNvSpPr/>
-          <p:nvPr/>
-        </p:nvSpPr>
-        <p:spPr>
-          <a:xfrm>
-            <a:off x="4168749" y="5257800"/>
-            <a:ext cx="1078992" cy="384048"/>
-          </a:xfrm>
-          <a:prstGeom prst="roundRect">
-            <a:avLst/>
-          </a:prstGeom>
-          <a:solidFill>
-            <a:srgbClr val="E8E8ED"/>
-          </a:solidFill>
-          <a:ln>
-            <a:noFill/>
-          </a:ln>
-        </p:spPr>
-        <p:style>
-          <a:lnRef idx="1">
-            <a:schemeClr val="accent1"/>
-          </a:lnRef>
-          <a:fillRef idx="3">
-            <a:schemeClr val="accent1"/>
-          </a:fillRef>
-          <a:effectRef idx="2">
-            <a:schemeClr val="accent1"/>
-          </a:effectRef>
-          <a:fontRef idx="minor">
-            <a:schemeClr val="lt1"/>
-          </a:fontRef>
-        </p:style>
-        <p:txBody>
-          <a:bodyPr rtlCol="0" anchor="ctr"/>
-          <a:lstStyle/>
-          <a:p>
-            <a:pPr algn="ctr"/>
-          </a:p>
-        </p:txBody>
-      </p:sp>
-      <p:sp>
-        <p:nvSpPr>
-          <p:cNvPr id="5" name="TextBox 4"/>
-          <p:cNvSpPr txBox="1"/>
-          <p:nvPr/>
-        </p:nvSpPr>
-        <p:spPr>
-          <a:xfrm>
-            <a:off x="4168749" y="5294376"/>
-            <a:ext cx="1078992" cy="329184"/>
-          </a:xfrm>
-          <a:prstGeom prst="rect">
-            <a:avLst/>
-          </a:prstGeom>
-          <a:noFill/>
-        </p:spPr>
-        <p:txBody>
-          <a:bodyPr wrap="square">
-            <a:spAutoFit/>
-          </a:bodyPr>
-          <a:lstStyle/>
-          <a:p>
-            <a:pPr algn="ctr"/>
-            <a:r>
-              <a:rPr sz="1200" b="1">
-                <a:solidFill>
-                  <a:srgbClr val="1D1D1F"/>
-                </a:solidFill>
-                <a:latin typeface="Calibri"/>
-              </a:rPr>
-              <a:t>Deployed</a:t>
-            </a:r>
-          </a:p>
-        </p:txBody>
-      </p:sp>
-      <p:sp>
-        <p:nvSpPr>
-          <p:cNvPr id="6" name="Rounded Rectangle 5"/>
-          <p:cNvSpPr/>
-          <p:nvPr/>
-        </p:nvSpPr>
-        <p:spPr>
-          <a:xfrm>
-            <a:off x="5412333" y="5257800"/>
-            <a:ext cx="886968" cy="384048"/>
-          </a:xfrm>
-          <a:prstGeom prst="roundRect">
-            <a:avLst/>
-          </a:prstGeom>
-          <a:solidFill>
-            <a:srgbClr val="E8E8ED"/>
-          </a:solidFill>
-          <a:ln>
-            <a:noFill/>
-          </a:ln>
-        </p:spPr>
-        <p:style>
-          <a:lnRef idx="1">
-            <a:schemeClr val="accent1"/>
-          </a:lnRef>
-          <a:fillRef idx="3">
-            <a:schemeClr val="accent1"/>
-          </a:fillRef>
-          <a:effectRef idx="2">
-            <a:schemeClr val="accent1"/>
-          </a:effectRef>
-          <a:fontRef idx="minor">
-            <a:schemeClr val="lt1"/>
-          </a:fontRef>
-        </p:style>
-        <p:txBody>
-          <a:bodyPr rtlCol="0" anchor="ctr"/>
-          <a:lstStyle/>
-          <a:p>
-            <a:pPr algn="ctr"/>
-          </a:p>
-        </p:txBody>
-      </p:sp>
-      <p:sp>
-        <p:nvSpPr>
-          <p:cNvPr id="7" name="TextBox 6"/>
-          <p:cNvSpPr txBox="1"/>
-          <p:nvPr/>
-        </p:nvSpPr>
-        <p:spPr>
-          <a:xfrm>
-            <a:off x="5412333" y="5294376"/>
-            <a:ext cx="886968" cy="329184"/>
-          </a:xfrm>
-          <a:prstGeom prst="rect">
-            <a:avLst/>
-          </a:prstGeom>
-          <a:noFill/>
-        </p:spPr>
-        <p:txBody>
-          <a:bodyPr wrap="square">
-            <a:spAutoFit/>
-          </a:bodyPr>
-          <a:lstStyle/>
-          <a:p>
-            <a:pPr algn="ctr"/>
-            <a:r>
-              <a:rPr sz="1200" b="1">
-                <a:solidFill>
-                  <a:srgbClr val="1D1D1F"/>
-                </a:solidFill>
-                <a:latin typeface="Calibri"/>
-              </a:rPr>
-              <a:t>Usable</a:t>
-            </a:r>
-          </a:p>
-        </p:txBody>
-      </p:sp>
-      <p:sp>
-        <p:nvSpPr>
-          <p:cNvPr id="8" name="Rounded Rectangle 7"/>
-          <p:cNvSpPr/>
-          <p:nvPr/>
-        </p:nvSpPr>
-        <p:spPr>
-          <a:xfrm>
-            <a:off x="6463893" y="5257800"/>
-            <a:ext cx="1559052" cy="384048"/>
-          </a:xfrm>
-          <a:prstGeom prst="roundRect">
-            <a:avLst/>
-          </a:prstGeom>
-          <a:solidFill>
-            <a:srgbClr val="E8E8ED"/>
-          </a:solidFill>
-          <a:ln>
-            <a:noFill/>
-          </a:ln>
-        </p:spPr>
-        <p:style>
-          <a:lnRef idx="1">
-            <a:schemeClr val="accent1"/>
-          </a:lnRef>
-          <a:fillRef idx="3">
-            <a:schemeClr val="accent1"/>
-          </a:fillRef>
-          <a:effectRef idx="2">
-            <a:schemeClr val="accent1"/>
-          </a:effectRef>
-          <a:fontRef idx="minor">
-            <a:schemeClr val="lt1"/>
-          </a:fontRef>
-        </p:style>
-        <p:txBody>
-          <a:bodyPr rtlCol="0" anchor="ctr"/>
-          <a:lstStyle/>
-          <a:p>
-            <a:pPr algn="ctr"/>
-          </a:p>
-        </p:txBody>
-      </p:sp>
-      <p:sp>
-        <p:nvSpPr>
-          <p:cNvPr id="9" name="TextBox 8"/>
-          <p:cNvSpPr txBox="1"/>
-          <p:nvPr/>
-        </p:nvSpPr>
-        <p:spPr>
-          <a:xfrm>
-            <a:off x="6463893" y="5294376"/>
-            <a:ext cx="1559052" cy="329184"/>
-          </a:xfrm>
-          <a:prstGeom prst="rect">
-            <a:avLst/>
-          </a:prstGeom>
-          <a:noFill/>
-        </p:spPr>
-        <p:txBody>
-          <a:bodyPr wrap="square">
-            <a:spAutoFit/>
-          </a:bodyPr>
-          <a:lstStyle/>
-          <a:p>
-            <a:pPr algn="ctr"/>
-            <a:r>
-              <a:rPr sz="1200" b="1">
-                <a:solidFill>
-                  <a:srgbClr val="1D1D1F"/>
-                </a:solidFill>
-                <a:latin typeface="Calibri"/>
-              </a:rPr>
-              <a:t>Payments work</a:t>
-            </a:r>
-          </a:p>
-        </p:txBody>
-      </p:sp>
+              <a:t>One sheet. Set Review Ready.</a:t>
+            </a:r>
+          </a:p>
+        </p:txBody>
+      </p:sp>
+      <p:pic>
+        <p:nvPicPr>
+          <p:cNvPr id="4" name="Picture 3" descr="shipaton-sheet-qr.png"/>
+          <p:cNvPicPr>
+            <a:picLocks noChangeAspect="1"/>
+          </p:cNvPicPr>
+          <p:nvPr/>
+        </p:nvPicPr>
+        <p:blipFill>
+          <a:blip r:embed="rId2"/>
+          <a:stretch>
+            <a:fillRect/>
+          </a:stretch>
+        </p:blipFill>
+        <p:spPr>
+          <a:xfrm>
+            <a:off x="4160520" y="1965960"/>
+            <a:ext cx="3840480" cy="3840480"/>
+          </a:xfrm>
+          <a:prstGeom prst="rect">
+            <a:avLst/>
+          </a:prstGeom>
+        </p:spPr>
+      </p:pic>
     </p:spTree>
   </p:cSld>
   <p:clrMapOvr>
@@ -10408,8 +10400,8 @@
         </p:nvSpPr>
         <p:spPr>
           <a:xfrm>
-            <a:off x="640080" y="1051560"/>
-            <a:ext cx="10881360" cy="1005840"/>
+            <a:off x="640080" y="1874519"/>
+            <a:ext cx="10881360" cy="1737360"/>
           </a:xfrm>
           <a:prstGeom prst="rect">
             <a:avLst/>
@@ -10424,97 +10416,27 @@
           <a:p>
             <a:pPr algn="ctr"/>
             <a:r>
-              <a:rPr sz="3600" b="1">
+              <a:rPr sz="4000" b="1">
                 <a:solidFill>
                   <a:srgbClr val="1D1D1F"/>
                 </a:solidFill>
                 <a:latin typeface="Calibri"/>
               </a:rPr>
-              <a:t>Ship it. Get reviewed.</a:t>
-            </a:r>
-          </a:p>
-        </p:txBody>
-      </p:sp>
-      <p:sp>
-        <p:nvSpPr>
-          <p:cNvPr id="4" name="TextBox 3"/>
-          <p:cNvSpPr txBox="1"/>
-          <p:nvPr/>
-        </p:nvSpPr>
-        <p:spPr>
-          <a:xfrm>
-            <a:off x="822960" y="2331720"/>
-            <a:ext cx="10515600" cy="1828800"/>
-          </a:xfrm>
-          <a:prstGeom prst="rect">
-            <a:avLst/>
-          </a:prstGeom>
-          <a:noFill/>
-        </p:spPr>
-        <p:txBody>
-          <a:bodyPr wrap="square">
-            <a:spAutoFit/>
-          </a:bodyPr>
-          <a:lstStyle/>
-          <a:p>
-            <a:pPr algn="ctr"/>
-            <a:r>
-              <a:rPr sz="2400" b="1">
-                <a:solidFill>
-                  <a:srgbClr val="1D1D1F"/>
-                </a:solidFill>
-                <a:latin typeface="Calibri"/>
-              </a:rPr>
-              <a:t>We're going to see 10 person billion-dollar companies pretty soon.</a:t>
-            </a:r>
-          </a:p>
-        </p:txBody>
-      </p:sp>
-      <p:sp>
-        <p:nvSpPr>
-          <p:cNvPr id="5" name="TextBox 4"/>
-          <p:cNvSpPr txBox="1"/>
-          <p:nvPr/>
-        </p:nvSpPr>
-        <p:spPr>
-          <a:xfrm>
-            <a:off x="640080" y="4297680"/>
-            <a:ext cx="10881360" cy="365760"/>
-          </a:xfrm>
-          <a:prstGeom prst="rect">
-            <a:avLst/>
-          </a:prstGeom>
-          <a:noFill/>
-        </p:spPr>
-        <p:txBody>
-          <a:bodyPr wrap="square">
-            <a:spAutoFit/>
-          </a:bodyPr>
-          <a:lstStyle/>
-          <a:p>
-            <a:pPr algn="ctr"/>
-            <a:r>
-              <a:rPr sz="1400" b="1">
-                <a:solidFill>
-                  <a:srgbClr val="6E6E73"/>
-                </a:solidFill>
-                <a:latin typeface="Calibri"/>
-              </a:rPr>
-              <a:t>Sam Altman</a:t>
-            </a:r>
-          </a:p>
-        </p:txBody>
-      </p:sp>
-      <p:sp>
-        <p:nvSpPr>
-          <p:cNvPr id="6" name="Rounded Rectangle 5"/>
+              <a:t>Thursday. Make it live.</a:t>
+            </a:r>
+          </a:p>
+        </p:txBody>
+      </p:sp>
+      <p:sp>
+        <p:nvSpPr>
+          <p:cNvPr id="4" name="Rounded Rectangle 3"/>
           <p:cNvSpPr/>
           <p:nvPr/>
         </p:nvSpPr>
         <p:spPr>
           <a:xfrm>
-            <a:off x="5220309" y="5257800"/>
-            <a:ext cx="1751076" cy="384048"/>
+            <a:off x="4168749" y="5257800"/>
+            <a:ext cx="1078992" cy="384048"/>
           </a:xfrm>
           <a:prstGeom prst="roundRect">
             <a:avLst/>
@@ -10550,14 +10472,14 @@
       </p:sp>
       <p:sp>
         <p:nvSpPr>
-          <p:cNvPr id="7" name="TextBox 6"/>
+          <p:cNvPr id="5" name="TextBox 4"/>
           <p:cNvSpPr txBox="1"/>
           <p:nvPr/>
         </p:nvSpPr>
         <p:spPr>
           <a:xfrm>
-            <a:off x="5220309" y="5294376"/>
-            <a:ext cx="1751076" cy="329184"/>
+            <a:off x="4168749" y="5294376"/>
+            <a:ext cx="1078992" cy="329184"/>
           </a:xfrm>
           <a:prstGeom prst="rect">
             <a:avLst/>
@@ -10578,7 +10500,163 @@
                 </a:solidFill>
                 <a:latin typeface="Calibri"/>
               </a:rPr>
-              <a:t>DevFest tickets</a:t>
+              <a:t>Deployed</a:t>
+            </a:r>
+          </a:p>
+        </p:txBody>
+      </p:sp>
+      <p:sp>
+        <p:nvSpPr>
+          <p:cNvPr id="6" name="Rounded Rectangle 5"/>
+          <p:cNvSpPr/>
+          <p:nvPr/>
+        </p:nvSpPr>
+        <p:spPr>
+          <a:xfrm>
+            <a:off x="5412333" y="5257800"/>
+            <a:ext cx="886968" cy="384048"/>
+          </a:xfrm>
+          <a:prstGeom prst="roundRect">
+            <a:avLst/>
+          </a:prstGeom>
+          <a:solidFill>
+            <a:srgbClr val="E8E8ED"/>
+          </a:solidFill>
+          <a:ln>
+            <a:noFill/>
+          </a:ln>
+        </p:spPr>
+        <p:style>
+          <a:lnRef idx="1">
+            <a:schemeClr val="accent1"/>
+          </a:lnRef>
+          <a:fillRef idx="3">
+            <a:schemeClr val="accent1"/>
+          </a:fillRef>
+          <a:effectRef idx="2">
+            <a:schemeClr val="accent1"/>
+          </a:effectRef>
+          <a:fontRef idx="minor">
+            <a:schemeClr val="lt1"/>
+          </a:fontRef>
+        </p:style>
+        <p:txBody>
+          <a:bodyPr rtlCol="0" anchor="ctr"/>
+          <a:lstStyle/>
+          <a:p>
+            <a:pPr algn="ctr"/>
+          </a:p>
+        </p:txBody>
+      </p:sp>
+      <p:sp>
+        <p:nvSpPr>
+          <p:cNvPr id="7" name="TextBox 6"/>
+          <p:cNvSpPr txBox="1"/>
+          <p:nvPr/>
+        </p:nvSpPr>
+        <p:spPr>
+          <a:xfrm>
+            <a:off x="5412333" y="5294376"/>
+            <a:ext cx="886968" cy="329184"/>
+          </a:xfrm>
+          <a:prstGeom prst="rect">
+            <a:avLst/>
+          </a:prstGeom>
+          <a:noFill/>
+        </p:spPr>
+        <p:txBody>
+          <a:bodyPr wrap="square">
+            <a:spAutoFit/>
+          </a:bodyPr>
+          <a:lstStyle/>
+          <a:p>
+            <a:pPr algn="ctr"/>
+            <a:r>
+              <a:rPr sz="1200" b="1">
+                <a:solidFill>
+                  <a:srgbClr val="1D1D1F"/>
+                </a:solidFill>
+                <a:latin typeface="Calibri"/>
+              </a:rPr>
+              <a:t>Usable</a:t>
+            </a:r>
+          </a:p>
+        </p:txBody>
+      </p:sp>
+      <p:sp>
+        <p:nvSpPr>
+          <p:cNvPr id="8" name="Rounded Rectangle 7"/>
+          <p:cNvSpPr/>
+          <p:nvPr/>
+        </p:nvSpPr>
+        <p:spPr>
+          <a:xfrm>
+            <a:off x="6463893" y="5257800"/>
+            <a:ext cx="1559052" cy="384048"/>
+          </a:xfrm>
+          <a:prstGeom prst="roundRect">
+            <a:avLst/>
+          </a:prstGeom>
+          <a:solidFill>
+            <a:srgbClr val="E8E8ED"/>
+          </a:solidFill>
+          <a:ln>
+            <a:noFill/>
+          </a:ln>
+        </p:spPr>
+        <p:style>
+          <a:lnRef idx="1">
+            <a:schemeClr val="accent1"/>
+          </a:lnRef>
+          <a:fillRef idx="3">
+            <a:schemeClr val="accent1"/>
+          </a:fillRef>
+          <a:effectRef idx="2">
+            <a:schemeClr val="accent1"/>
+          </a:effectRef>
+          <a:fontRef idx="minor">
+            <a:schemeClr val="lt1"/>
+          </a:fontRef>
+        </p:style>
+        <p:txBody>
+          <a:bodyPr rtlCol="0" anchor="ctr"/>
+          <a:lstStyle/>
+          <a:p>
+            <a:pPr algn="ctr"/>
+          </a:p>
+        </p:txBody>
+      </p:sp>
+      <p:sp>
+        <p:nvSpPr>
+          <p:cNvPr id="9" name="TextBox 8"/>
+          <p:cNvSpPr txBox="1"/>
+          <p:nvPr/>
+        </p:nvSpPr>
+        <p:spPr>
+          <a:xfrm>
+            <a:off x="6463893" y="5294376"/>
+            <a:ext cx="1559052" cy="329184"/>
+          </a:xfrm>
+          <a:prstGeom prst="rect">
+            <a:avLst/>
+          </a:prstGeom>
+          <a:noFill/>
+        </p:spPr>
+        <p:txBody>
+          <a:bodyPr wrap="square">
+            <a:spAutoFit/>
+          </a:bodyPr>
+          <a:lstStyle/>
+          <a:p>
+            <a:pPr algn="ctr"/>
+            <a:r>
+              <a:rPr sz="1200" b="1">
+                <a:solidFill>
+                  <a:srgbClr val="1D1D1F"/>
+                </a:solidFill>
+                <a:latin typeface="Calibri"/>
+              </a:rPr>
+              <a:t>Payments work</a:t>
             </a:r>
           </a:p>
         </p:txBody>
@@ -10652,8 +10730,8 @@
         </p:nvSpPr>
         <p:spPr>
           <a:xfrm>
-            <a:off x="640080" y="1554480"/>
-            <a:ext cx="10881360" cy="1737360"/>
+            <a:off x="640080" y="1051560"/>
+            <a:ext cx="10881360" cy="1005840"/>
           </a:xfrm>
           <a:prstGeom prst="rect">
             <a:avLst/>
@@ -10668,13 +10746,13 @@
           <a:p>
             <a:pPr algn="ctr"/>
             <a:r>
-              <a:rPr sz="3400" b="1">
+              <a:rPr sz="3600" b="1">
                 <a:solidFill>
                   <a:srgbClr val="1D1D1F"/>
                 </a:solidFill>
                 <a:latin typeface="Calibri"/>
               </a:rPr>
-              <a:t>Just follow these for now.</a:t>
+              <a:t>Ship it. Get reviewed.</a:t>
             </a:r>
           </a:p>
         </p:txBody>
@@ -10687,8 +10765,8 @@
         </p:nvSpPr>
         <p:spPr>
           <a:xfrm>
-            <a:off x="640080" y="3337560"/>
-            <a:ext cx="10881360" cy="777240"/>
+            <a:off x="822960" y="2331720"/>
+            <a:ext cx="10515600" cy="1828800"/>
           </a:xfrm>
           <a:prstGeom prst="rect">
             <a:avLst/>
@@ -10703,27 +10781,62 @@
           <a:p>
             <a:pPr algn="ctr"/>
             <a:r>
-              <a:rPr sz="2200" b="0">
+              <a:rPr sz="2400" b="1">
+                <a:solidFill>
+                  <a:srgbClr val="1D1D1F"/>
+                </a:solidFill>
+                <a:latin typeface="Calibri"/>
+              </a:rPr>
+              <a:t>We're going to see 10 person billion-dollar companies pretty soon.</a:t>
+            </a:r>
+          </a:p>
+        </p:txBody>
+      </p:sp>
+      <p:sp>
+        <p:nvSpPr>
+          <p:cNvPr id="5" name="TextBox 4"/>
+          <p:cNvSpPr txBox="1"/>
+          <p:nvPr/>
+        </p:nvSpPr>
+        <p:spPr>
+          <a:xfrm>
+            <a:off x="640080" y="4297680"/>
+            <a:ext cx="10881360" cy="365760"/>
+          </a:xfrm>
+          <a:prstGeom prst="rect">
+            <a:avLst/>
+          </a:prstGeom>
+          <a:noFill/>
+        </p:spPr>
+        <p:txBody>
+          <a:bodyPr wrap="square">
+            <a:spAutoFit/>
+          </a:bodyPr>
+          <a:lstStyle/>
+          <a:p>
+            <a:pPr algn="ctr"/>
+            <a:r>
+              <a:rPr sz="1400" b="1">
                 <a:solidFill>
                   <a:srgbClr val="6E6E73"/>
                 </a:solidFill>
                 <a:latin typeface="Calibri"/>
               </a:rPr>
-              <a:t>Don't get overwhelmed.</a:t>
-            </a:r>
-          </a:p>
-        </p:txBody>
-      </p:sp>
-      <p:sp>
-        <p:nvSpPr>
-          <p:cNvPr id="5" name="Rounded Rectangle 4"/>
+              <a:t>Sam Altman</a:t>
+            </a:r>
+          </a:p>
+        </p:txBody>
+      </p:sp>
+      <p:sp>
+        <p:nvSpPr>
+          <p:cNvPr id="6" name="Rounded Rectangle 5"/>
           <p:cNvSpPr/>
           <p:nvPr/>
         </p:nvSpPr>
         <p:spPr>
           <a:xfrm>
-            <a:off x="4168749" y="5074920"/>
-            <a:ext cx="406908" cy="384048"/>
+            <a:off x="5220309" y="5257800"/>
+            <a:ext cx="1751076" cy="384048"/>
           </a:xfrm>
           <a:prstGeom prst="roundRect">
             <a:avLst/>
@@ -10759,14 +10872,14 @@
       </p:sp>
       <p:sp>
         <p:nvSpPr>
-          <p:cNvPr id="6" name="TextBox 5"/>
+          <p:cNvPr id="7" name="TextBox 6"/>
           <p:cNvSpPr txBox="1"/>
           <p:nvPr/>
         </p:nvSpPr>
         <p:spPr>
           <a:xfrm>
-            <a:off x="4168749" y="5111496"/>
-            <a:ext cx="406908" cy="329184"/>
+            <a:off x="5220309" y="5294376"/>
+            <a:ext cx="1751076" cy="329184"/>
           </a:xfrm>
           <a:prstGeom prst="rect">
             <a:avLst/>
@@ -10787,163 +10900,7 @@
                 </a:solidFill>
                 <a:latin typeface="Calibri"/>
               </a:rPr>
-              <a:t>X</a:t>
-            </a:r>
-          </a:p>
-        </p:txBody>
-      </p:sp>
-      <p:sp>
-        <p:nvSpPr>
-          <p:cNvPr id="7" name="Rounded Rectangle 6"/>
-          <p:cNvSpPr/>
-          <p:nvPr/>
-        </p:nvSpPr>
-        <p:spPr>
-          <a:xfrm>
-            <a:off x="4740249" y="5074920"/>
-            <a:ext cx="1463040" cy="384048"/>
-          </a:xfrm>
-          <a:prstGeom prst="roundRect">
-            <a:avLst/>
-          </a:prstGeom>
-          <a:solidFill>
-            <a:srgbClr val="E8E8ED"/>
-          </a:solidFill>
-          <a:ln>
-            <a:noFill/>
-          </a:ln>
-        </p:spPr>
-        <p:style>
-          <a:lnRef idx="1">
-            <a:schemeClr val="accent1"/>
-          </a:lnRef>
-          <a:fillRef idx="3">
-            <a:schemeClr val="accent1"/>
-          </a:fillRef>
-          <a:effectRef idx="2">
-            <a:schemeClr val="accent1"/>
-          </a:effectRef>
-          <a:fontRef idx="minor">
-            <a:schemeClr val="lt1"/>
-          </a:fontRef>
-        </p:style>
-        <p:txBody>
-          <a:bodyPr rtlCol="0" anchor="ctr"/>
-          <a:lstStyle/>
-          <a:p>
-            <a:pPr algn="ctr"/>
-          </a:p>
-        </p:txBody>
-      </p:sp>
-      <p:sp>
-        <p:nvSpPr>
-          <p:cNvPr id="8" name="TextBox 7"/>
-          <p:cNvSpPr txBox="1"/>
-          <p:nvPr/>
-        </p:nvSpPr>
-        <p:spPr>
-          <a:xfrm>
-            <a:off x="4740249" y="5111496"/>
-            <a:ext cx="1463040" cy="329184"/>
-          </a:xfrm>
-          <a:prstGeom prst="rect">
-            <a:avLst/>
-          </a:prstGeom>
-          <a:noFill/>
-        </p:spPr>
-        <p:txBody>
-          <a:bodyPr wrap="square">
-            <a:spAutoFit/>
-          </a:bodyPr>
-          <a:lstStyle/>
-          <a:p>
-            <a:pPr algn="ctr"/>
-            <a:r>
-              <a:rPr sz="1200" b="1">
-                <a:solidFill>
-                  <a:srgbClr val="1D1D1F"/>
-                </a:solidFill>
-                <a:latin typeface="Calibri"/>
-              </a:rPr>
-              <a:t>Product Hunt</a:t>
-            </a:r>
-          </a:p>
-        </p:txBody>
-      </p:sp>
-      <p:sp>
-        <p:nvSpPr>
-          <p:cNvPr id="9" name="Rounded Rectangle 8"/>
-          <p:cNvSpPr/>
-          <p:nvPr/>
-        </p:nvSpPr>
-        <p:spPr>
-          <a:xfrm>
-            <a:off x="6367881" y="5074920"/>
-            <a:ext cx="1655064" cy="384048"/>
-          </a:xfrm>
-          <a:prstGeom prst="roundRect">
-            <a:avLst/>
-          </a:prstGeom>
-          <a:solidFill>
-            <a:srgbClr val="E8E8ED"/>
-          </a:solidFill>
-          <a:ln>
-            <a:noFill/>
-          </a:ln>
-        </p:spPr>
-        <p:style>
-          <a:lnRef idx="1">
-            <a:schemeClr val="accent1"/>
-          </a:lnRef>
-          <a:fillRef idx="3">
-            <a:schemeClr val="accent1"/>
-          </a:fillRef>
-          <a:effectRef idx="2">
-            <a:schemeClr val="accent1"/>
-          </a:effectRef>
-          <a:fontRef idx="minor">
-            <a:schemeClr val="lt1"/>
-          </a:fontRef>
-        </p:style>
-        <p:txBody>
-          <a:bodyPr rtlCol="0" anchor="ctr"/>
-          <a:lstStyle/>
-          <a:p>
-            <a:pPr algn="ctr"/>
-          </a:p>
-        </p:txBody>
-      </p:sp>
-      <p:sp>
-        <p:nvSpPr>
-          <p:cNvPr id="10" name="TextBox 9"/>
-          <p:cNvSpPr txBox="1"/>
-          <p:nvPr/>
-        </p:nvSpPr>
-        <p:spPr>
-          <a:xfrm>
-            <a:off x="6367881" y="5111496"/>
-            <a:ext cx="1655064" cy="329184"/>
-          </a:xfrm>
-          <a:prstGeom prst="rect">
-            <a:avLst/>
-          </a:prstGeom>
-          <a:noFill/>
-        </p:spPr>
-        <p:txBody>
-          <a:bodyPr wrap="square">
-            <a:spAutoFit/>
-          </a:bodyPr>
-          <a:lstStyle/>
-          <a:p>
-            <a:pPr algn="ctr"/>
-            <a:r>
-              <a:rPr sz="1200" b="1">
-                <a:solidFill>
-                  <a:srgbClr val="1D1D1F"/>
-                </a:solidFill>
-                <a:latin typeface="Calibri"/>
-              </a:rPr>
-              <a:t>Startup School</a:t>
+              <a:t>DevFest tickets</a:t>
             </a:r>
           </a:p>
         </p:txBody>
@@ -11017,8 +10974,8 @@
         </p:nvSpPr>
         <p:spPr>
           <a:xfrm>
-            <a:off x="640080" y="640080"/>
-            <a:ext cx="10881360" cy="1051560"/>
+            <a:off x="640080" y="1554480"/>
+            <a:ext cx="10881360" cy="1737360"/>
           </a:xfrm>
           <a:prstGeom prst="rect">
             <a:avLst/>
@@ -11033,13 +10990,13 @@
           <a:p>
             <a:pPr algn="ctr"/>
             <a:r>
-              <a:rPr sz="3600" b="1">
+              <a:rPr sz="3400" b="1">
                 <a:solidFill>
                   <a:srgbClr val="1D1D1F"/>
                 </a:solidFill>
                 <a:latin typeface="Calibri"/>
               </a:rPr>
-              <a:t>Take Startup School.</a:t>
+              <a:t>Just follow these for now.</a:t>
             </a:r>
           </a:p>
         </p:txBody>
@@ -11052,8 +11009,8 @@
         </p:nvSpPr>
         <p:spPr>
           <a:xfrm>
-            <a:off x="640080" y="1737360"/>
-            <a:ext cx="10881360" cy="502920"/>
+            <a:off x="640080" y="3337560"/>
+            <a:ext cx="10881360" cy="777240"/>
           </a:xfrm>
           <a:prstGeom prst="rect">
             <a:avLst/>
@@ -11074,35 +11031,245 @@
                 </a:solidFill>
                 <a:latin typeface="Calibri"/>
               </a:rPr>
-              <a:t>Free. Online. From YC.</a:t>
-            </a:r>
-          </a:p>
-        </p:txBody>
-      </p:sp>
-      <p:pic>
-        <p:nvPicPr>
-          <p:cNvPr id="5" name="Picture 4" descr="startup-school-qr.png"/>
-          <p:cNvPicPr>
-            <a:picLocks noChangeAspect="1"/>
-          </p:cNvPicPr>
-          <p:nvPr/>
-        </p:nvPicPr>
-        <p:blipFill>
-          <a:blip r:embed="rId2"/>
-          <a:stretch>
-            <a:fillRect/>
-          </a:stretch>
-        </p:blipFill>
-        <p:spPr>
-          <a:xfrm>
-            <a:off x="4160520" y="2331720"/>
-            <a:ext cx="3840480" cy="3840480"/>
-          </a:xfrm>
-          <a:prstGeom prst="rect">
-            <a:avLst/>
-          </a:prstGeom>
-        </p:spPr>
-      </p:pic>
+              <a:t>Don't get overwhelmed.</a:t>
+            </a:r>
+          </a:p>
+        </p:txBody>
+      </p:sp>
+      <p:sp>
+        <p:nvSpPr>
+          <p:cNvPr id="5" name="Rounded Rectangle 4"/>
+          <p:cNvSpPr/>
+          <p:nvPr/>
+        </p:nvSpPr>
+        <p:spPr>
+          <a:xfrm>
+            <a:off x="4168749" y="5074920"/>
+            <a:ext cx="406908" cy="384048"/>
+          </a:xfrm>
+          <a:prstGeom prst="roundRect">
+            <a:avLst/>
+          </a:prstGeom>
+          <a:solidFill>
+            <a:srgbClr val="E8E8ED"/>
+          </a:solidFill>
+          <a:ln>
+            <a:noFill/>
+          </a:ln>
+        </p:spPr>
+        <p:style>
+          <a:lnRef idx="1">
+            <a:schemeClr val="accent1"/>
+          </a:lnRef>
+          <a:fillRef idx="3">
+            <a:schemeClr val="accent1"/>
+          </a:fillRef>
+          <a:effectRef idx="2">
+            <a:schemeClr val="accent1"/>
+          </a:effectRef>
+          <a:fontRef idx="minor">
+            <a:schemeClr val="lt1"/>
+          </a:fontRef>
+        </p:style>
+        <p:txBody>
+          <a:bodyPr rtlCol="0" anchor="ctr"/>
+          <a:lstStyle/>
+          <a:p>
+            <a:pPr algn="ctr"/>
+          </a:p>
+        </p:txBody>
+      </p:sp>
+      <p:sp>
+        <p:nvSpPr>
+          <p:cNvPr id="6" name="TextBox 5"/>
+          <p:cNvSpPr txBox="1"/>
+          <p:nvPr/>
+        </p:nvSpPr>
+        <p:spPr>
+          <a:xfrm>
+            <a:off x="4168749" y="5111496"/>
+            <a:ext cx="406908" cy="329184"/>
+          </a:xfrm>
+          <a:prstGeom prst="rect">
+            <a:avLst/>
+          </a:prstGeom>
+          <a:noFill/>
+        </p:spPr>
+        <p:txBody>
+          <a:bodyPr wrap="square">
+            <a:spAutoFit/>
+          </a:bodyPr>
+          <a:lstStyle/>
+          <a:p>
+            <a:pPr algn="ctr"/>
+            <a:r>
+              <a:rPr sz="1200" b="1">
+                <a:solidFill>
+                  <a:srgbClr val="1D1D1F"/>
+                </a:solidFill>
+                <a:latin typeface="Calibri"/>
+              </a:rPr>
+              <a:t>X</a:t>
+            </a:r>
+          </a:p>
+        </p:txBody>
+      </p:sp>
+      <p:sp>
+        <p:nvSpPr>
+          <p:cNvPr id="7" name="Rounded Rectangle 6"/>
+          <p:cNvSpPr/>
+          <p:nvPr/>
+        </p:nvSpPr>
+        <p:spPr>
+          <a:xfrm>
+            <a:off x="4740249" y="5074920"/>
+            <a:ext cx="1463040" cy="384048"/>
+          </a:xfrm>
+          <a:prstGeom prst="roundRect">
+            <a:avLst/>
+          </a:prstGeom>
+          <a:solidFill>
+            <a:srgbClr val="E8E8ED"/>
+          </a:solidFill>
+          <a:ln>
+            <a:noFill/>
+          </a:ln>
+        </p:spPr>
+        <p:style>
+          <a:lnRef idx="1">
+            <a:schemeClr val="accent1"/>
+          </a:lnRef>
+          <a:fillRef idx="3">
+            <a:schemeClr val="accent1"/>
+          </a:fillRef>
+          <a:effectRef idx="2">
+            <a:schemeClr val="accent1"/>
+          </a:effectRef>
+          <a:fontRef idx="minor">
+            <a:schemeClr val="lt1"/>
+          </a:fontRef>
+        </p:style>
+        <p:txBody>
+          <a:bodyPr rtlCol="0" anchor="ctr"/>
+          <a:lstStyle/>
+          <a:p>
+            <a:pPr algn="ctr"/>
+          </a:p>
+        </p:txBody>
+      </p:sp>
+      <p:sp>
+        <p:nvSpPr>
+          <p:cNvPr id="8" name="TextBox 7"/>
+          <p:cNvSpPr txBox="1"/>
+          <p:nvPr/>
+        </p:nvSpPr>
+        <p:spPr>
+          <a:xfrm>
+            <a:off x="4740249" y="5111496"/>
+            <a:ext cx="1463040" cy="329184"/>
+          </a:xfrm>
+          <a:prstGeom prst="rect">
+            <a:avLst/>
+          </a:prstGeom>
+          <a:noFill/>
+        </p:spPr>
+        <p:txBody>
+          <a:bodyPr wrap="square">
+            <a:spAutoFit/>
+          </a:bodyPr>
+          <a:lstStyle/>
+          <a:p>
+            <a:pPr algn="ctr"/>
+            <a:r>
+              <a:rPr sz="1200" b="1">
+                <a:solidFill>
+                  <a:srgbClr val="1D1D1F"/>
+                </a:solidFill>
+                <a:latin typeface="Calibri"/>
+              </a:rPr>
+              <a:t>Product Hunt</a:t>
+            </a:r>
+          </a:p>
+        </p:txBody>
+      </p:sp>
+      <p:sp>
+        <p:nvSpPr>
+          <p:cNvPr id="9" name="Rounded Rectangle 8"/>
+          <p:cNvSpPr/>
+          <p:nvPr/>
+        </p:nvSpPr>
+        <p:spPr>
+          <a:xfrm>
+            <a:off x="6367881" y="5074920"/>
+            <a:ext cx="1655064" cy="384048"/>
+          </a:xfrm>
+          <a:prstGeom prst="roundRect">
+            <a:avLst/>
+          </a:prstGeom>
+          <a:solidFill>
+            <a:srgbClr val="E8E8ED"/>
+          </a:solidFill>
+          <a:ln>
+            <a:noFill/>
+          </a:ln>
+        </p:spPr>
+        <p:style>
+          <a:lnRef idx="1">
+            <a:schemeClr val="accent1"/>
+          </a:lnRef>
+          <a:fillRef idx="3">
+            <a:schemeClr val="accent1"/>
+          </a:fillRef>
+          <a:effectRef idx="2">
+            <a:schemeClr val="accent1"/>
+          </a:effectRef>
+          <a:fontRef idx="minor">
+            <a:schemeClr val="lt1"/>
+          </a:fontRef>
+        </p:style>
+        <p:txBody>
+          <a:bodyPr rtlCol="0" anchor="ctr"/>
+          <a:lstStyle/>
+          <a:p>
+            <a:pPr algn="ctr"/>
+          </a:p>
+        </p:txBody>
+      </p:sp>
+      <p:sp>
+        <p:nvSpPr>
+          <p:cNvPr id="10" name="TextBox 9"/>
+          <p:cNvSpPr txBox="1"/>
+          <p:nvPr/>
+        </p:nvSpPr>
+        <p:spPr>
+          <a:xfrm>
+            <a:off x="6367881" y="5111496"/>
+            <a:ext cx="1655064" cy="329184"/>
+          </a:xfrm>
+          <a:prstGeom prst="rect">
+            <a:avLst/>
+          </a:prstGeom>
+          <a:noFill/>
+        </p:spPr>
+        <p:txBody>
+          <a:bodyPr wrap="square">
+            <a:spAutoFit/>
+          </a:bodyPr>
+          <a:lstStyle/>
+          <a:p>
+            <a:pPr algn="ctr"/>
+            <a:r>
+              <a:rPr sz="1200" b="1">
+                <a:solidFill>
+                  <a:srgbClr val="1D1D1F"/>
+                </a:solidFill>
+                <a:latin typeface="Calibri"/>
+              </a:rPr>
+              <a:t>Startup School</a:t>
+            </a:r>
+          </a:p>
+        </p:txBody>
+      </p:sp>
     </p:spTree>
   </p:cSld>
   <p:clrMapOvr>
@@ -11197,6 +11364,211 @@
 </file>
 
 <file path=ppt/slides/slide25.xml><?xml version="1.0" encoding="utf-8"?>
+<p:sld xmlns:a="http://schemas.openxmlformats.org/drawingml/2006/main" xmlns:p="http://schemas.openxmlformats.org/presentationml/2006/main" xmlns:r="http://schemas.openxmlformats.org/officeDocument/2006/relationships">
+  <p:cSld>
+    <p:spTree>
+      <p:nvGrpSpPr>
+        <p:cNvPr id="1" name=""/>
+        <p:cNvGrpSpPr/>
+        <p:nvPr/>
+      </p:nvGrpSpPr>
+      <p:grpSpPr/>
+      <p:sp>
+        <p:nvSpPr>
+          <p:cNvPr id="2" name="Rectangle 1"/>
+          <p:cNvSpPr/>
+          <p:nvPr/>
+        </p:nvSpPr>
+        <p:spPr>
+          <a:xfrm>
+            <a:off x="0" y="0"/>
+            <a:ext cx="12191695" cy="6858000"/>
+          </a:xfrm>
+          <a:prstGeom prst="rect">
+            <a:avLst/>
+          </a:prstGeom>
+          <a:solidFill>
+            <a:srgbClr val="070710"/>
+          </a:solidFill>
+          <a:ln>
+            <a:noFill/>
+          </a:ln>
+        </p:spPr>
+        <p:style>
+          <a:lnRef idx="1">
+            <a:schemeClr val="accent1"/>
+          </a:lnRef>
+          <a:fillRef idx="3">
+            <a:schemeClr val="accent1"/>
+          </a:fillRef>
+          <a:effectRef idx="2">
+            <a:schemeClr val="accent1"/>
+          </a:effectRef>
+          <a:fontRef idx="minor">
+            <a:schemeClr val="lt1"/>
+          </a:fontRef>
+        </p:style>
+        <p:txBody>
+          <a:bodyPr rtlCol="0" anchor="ctr"/>
+          <a:lstStyle/>
+          <a:p>
+            <a:pPr algn="ctr"/>
+          </a:p>
+        </p:txBody>
+      </p:sp>
+      <p:pic>
+        <p:nvPicPr>
+          <p:cNvPr id="3" name="Picture 2" descr="droidcon-india-partner-card.png"/>
+          <p:cNvPicPr>
+            <a:picLocks noChangeAspect="1"/>
+          </p:cNvPicPr>
+          <p:nvPr/>
+        </p:nvPicPr>
+        <p:blipFill>
+          <a:blip r:embed="rId2"/>
+          <a:stretch>
+            <a:fillRect/>
+          </a:stretch>
+        </p:blipFill>
+        <p:spPr>
+          <a:xfrm>
+            <a:off x="0" y="238839"/>
+            <a:ext cx="12191695" cy="6380320"/>
+          </a:xfrm>
+          <a:prstGeom prst="rect">
+            <a:avLst/>
+          </a:prstGeom>
+        </p:spPr>
+      </p:pic>
+    </p:spTree>
+  </p:cSld>
+  <p:clrMapOvr>
+    <a:masterClrMapping/>
+  </p:clrMapOvr>
+</p:sld>
+</file>
+
+<file path=ppt/slides/slide26.xml><?xml version="1.0" encoding="utf-8"?>
+<p:sld xmlns:a="http://schemas.openxmlformats.org/drawingml/2006/main" xmlns:p="http://schemas.openxmlformats.org/presentationml/2006/main" xmlns:r="http://schemas.openxmlformats.org/officeDocument/2006/relationships">
+  <p:cSld>
+    <p:spTree>
+      <p:nvGrpSpPr>
+        <p:cNvPr id="1" name=""/>
+        <p:cNvGrpSpPr/>
+        <p:nvPr/>
+      </p:nvGrpSpPr>
+      <p:grpSpPr/>
+      <p:sp>
+        <p:nvSpPr>
+          <p:cNvPr id="2" name="Rectangle 1"/>
+          <p:cNvSpPr/>
+          <p:nvPr/>
+        </p:nvSpPr>
+        <p:spPr>
+          <a:xfrm>
+            <a:off x="0" y="0"/>
+            <a:ext cx="12191695" cy="6858000"/>
+          </a:xfrm>
+          <a:prstGeom prst="rect">
+            <a:avLst/>
+          </a:prstGeom>
+          <a:solidFill>
+            <a:srgbClr val="F5F5F7"/>
+          </a:solidFill>
+          <a:ln>
+            <a:noFill/>
+          </a:ln>
+        </p:spPr>
+        <p:style>
+          <a:lnRef idx="1">
+            <a:schemeClr val="accent1"/>
+          </a:lnRef>
+          <a:fillRef idx="3">
+            <a:schemeClr val="accent1"/>
+          </a:fillRef>
+          <a:effectRef idx="2">
+            <a:schemeClr val="accent1"/>
+          </a:effectRef>
+          <a:fontRef idx="minor">
+            <a:schemeClr val="lt1"/>
+          </a:fontRef>
+        </p:style>
+        <p:txBody>
+          <a:bodyPr rtlCol="0" anchor="ctr"/>
+          <a:lstStyle/>
+          <a:p>
+            <a:pPr algn="ctr"/>
+          </a:p>
+        </p:txBody>
+      </p:sp>
+      <p:sp>
+        <p:nvSpPr>
+          <p:cNvPr id="3" name="TextBox 2"/>
+          <p:cNvSpPr txBox="1"/>
+          <p:nvPr/>
+        </p:nvSpPr>
+        <p:spPr>
+          <a:xfrm>
+            <a:off x="640080" y="502920"/>
+            <a:ext cx="10881360" cy="1143000"/>
+          </a:xfrm>
+          <a:prstGeom prst="rect">
+            <a:avLst/>
+          </a:prstGeom>
+          <a:noFill/>
+        </p:spPr>
+        <p:txBody>
+          <a:bodyPr wrap="square">
+            <a:spAutoFit/>
+          </a:bodyPr>
+          <a:lstStyle/>
+          <a:p>
+            <a:pPr algn="ctr"/>
+            <a:r>
+              <a:rPr sz="3000" b="1">
+                <a:solidFill>
+                  <a:srgbClr val="1D1D1F"/>
+                </a:solidFill>
+                <a:latin typeface="Calibri"/>
+              </a:rPr>
+              <a:t>KUG Chennai Volunteer Interest Form</a:t>
+            </a:r>
+          </a:p>
+        </p:txBody>
+      </p:sp>
+      <p:pic>
+        <p:nvPicPr>
+          <p:cNvPr id="4" name="Picture 3" descr="kug-volunteer-qr.png"/>
+          <p:cNvPicPr>
+            <a:picLocks noChangeAspect="1"/>
+          </p:cNvPicPr>
+          <p:nvPr/>
+        </p:nvPicPr>
+        <p:blipFill>
+          <a:blip r:embed="rId2"/>
+          <a:stretch>
+            <a:fillRect/>
+          </a:stretch>
+        </p:blipFill>
+        <p:spPr>
+          <a:xfrm>
+            <a:off x="3977639" y="1783080"/>
+            <a:ext cx="4206240" cy="4206240"/>
+          </a:xfrm>
+          <a:prstGeom prst="rect">
+            <a:avLst/>
+          </a:prstGeom>
+        </p:spPr>
+      </p:pic>
+    </p:spTree>
+  </p:cSld>
+  <p:clrMapOvr>
+    <a:masterClrMapping/>
+  </p:clrMapOvr>
+</p:sld>
+</file>
+
+<file path=ppt/slides/slide27.xml><?xml version="1.0" encoding="utf-8"?>
 <p:sld xmlns:a="http://schemas.openxmlformats.org/drawingml/2006/main" xmlns:p="http://schemas.openxmlformats.org/presentationml/2006/main" xmlns:r="http://schemas.openxmlformats.org/officeDocument/2006/relationships">
   <p:cSld>
     <p:spTree>

</xml_diff>

<commit_message>
Close the Shipaton deck with the prize-pool poster.
Ads sell the product, they do not sit inside it. The last slide keeps Jobs, shows today's prize pool, and points at the next billion.
</commit_message>
<xml_diff>
--- a/talks/whats-stopping-us-from-building-great-products-and-monetizing-them/whats-stopping-us-from-building-great-products-and-monetizing-them.pptx
+++ b/talks/whats-stopping-us-from-building-great-products-and-monetizing-them/whats-stopping-us-from-building-great-products-and-monetizing-them.pptx
@@ -923,7 +923,7 @@
           <a:lstStyle/>
           <a:p>
             <a:r>
-              <a:t>Tanglish: Growth team-oda velai-nu theriyum. AI era-la neenga pick up panna mudiyum. First product-ah valarunga. Use pannanavanga irukanum. Appuram ads.</a:t>
+              <a:t>Tanglish: Growth team-oda velai-nu theriyum. AI era-la neenga pick up panna mudiyum. First product-ah valarunga. Use pannanavanga irukanum. Appuram ads. Product sell panna ads. Product-ukkulley ads potta, puthiya user-ku bloatware-ah theriyum.</a:t>
             </a:r>
           </a:p>
           <a:p>
@@ -933,12 +933,17 @@
           </a:p>
           <a:p>
             <a:r>
-              <a:t>Grow the product first. Then revenue, like ads. When the topic is making money from the product, people have to be using it before ads. Do not skip the earlier payment slides. Customer checkout and ad revenue are different.</a:t>
-            </a:r>
-          </a:p>
-          <a:p>
-            <a:r>
-              <a:t>Ads: Google Ads, Meta ads, Apple Search Ads. Ads cost money.</a:t>
+              <a:t>Grow the product first. Then revenue, like ads. Run ads to sell the product. Don't put ads inside it.</a:t>
+            </a:r>
+          </a:p>
+          <a:p>
+            <a:r>
+              <a:t>When the topic is making money from the product, people have to be using it before ads. Do not skip the earlier payment slides. Customer checkout and ad revenue are different.</a:t>
+            </a:r>
+          </a:p>
+          <a:p>
+            <a:r>
+              <a:t>Google Ads, Meta ads, and Apple Search Ads are for reaching buyers. Ads inside the product feel like bloatware to someone who just arrived. Ads cost money.</a:t>
             </a:r>
           </a:p>
           <a:p>
@@ -2263,12 +2268,22 @@
           <a:lstStyle/>
           <a:p>
             <a:r>
-              <a:t>Tanglish: Crazy-nu ninaichavanga dhaan world-ah maathuvaanga.</a:t>
-            </a:r>
-          </a:p>
-          <a:p>
-            <a:r>
-              <a:t>Leave the line up. The people who are crazy enough to think they can change the world are the ones who do. Steve Jobs.</a:t>
+              <a:t>Tanglish: Crazy-nu ninaichavanga dhaan world-ah maathuvaanga. Indha prize pool innaiku. Next billion-ah next hackathon prize-nu nenaikunga.</a:t>
+            </a:r>
+          </a:p>
+          <a:p>
+            <a:r>
+              <a:t>Leave the poster up. It already prints today's prize pool. ₹12,000 is today's prize pool, as printed. Do not retype that number as a second headline. Do not split it, name winners, or promise the billion.</a:t>
+            </a:r>
+          </a:p>
+          <a:p>
+            <a:r>
+              <a:t>Keep the Steve Jobs line: The people who are crazy enough to think they can change the world are the ones who do.</a:t>
+            </a:r>
+          </a:p>
+          <a:p>
+            <a:r>
+              <a:t>The billion line is the push to keep shipping: Today's prize pool is this. Nothing else is stopping you from a $1 billion company very soon. Think of the next $1 billion as your next hackathon-winning prize.</a:t>
             </a:r>
           </a:p>
           <a:p>
@@ -7753,8 +7768,8 @@
         </p:nvSpPr>
         <p:spPr>
           <a:xfrm>
-            <a:off x="640080" y="2697480"/>
-            <a:ext cx="10881360" cy="502920"/>
+            <a:off x="640080" y="2487168"/>
+            <a:ext cx="10881360" cy="411480"/>
           </a:xfrm>
           <a:prstGeom prst="rect">
             <a:avLst/>
@@ -7769,7 +7784,7 @@
           <a:p>
             <a:pPr algn="ctr"/>
             <a:r>
-              <a:rPr sz="2000" b="1">
+              <a:rPr sz="1800" b="1">
                 <a:solidFill>
                   <a:srgbClr val="1D1D1F"/>
                 </a:solidFill>
@@ -7782,14 +7797,49 @@
       </p:sp>
       <p:sp>
         <p:nvSpPr>
-          <p:cNvPr id="6" name="Rounded Rectangle 5"/>
+          <p:cNvPr id="6" name="TextBox 5"/>
+          <p:cNvSpPr txBox="1"/>
+          <p:nvPr/>
+        </p:nvSpPr>
+        <p:spPr>
+          <a:xfrm>
+            <a:off x="640080" y="2907792"/>
+            <a:ext cx="10881360" cy="411480"/>
+          </a:xfrm>
+          <a:prstGeom prst="rect">
+            <a:avLst/>
+          </a:prstGeom>
+          <a:noFill/>
+        </p:spPr>
+        <p:txBody>
+          <a:bodyPr wrap="square">
+            <a:spAutoFit/>
+          </a:bodyPr>
+          <a:lstStyle/>
+          <a:p>
+            <a:pPr algn="ctr"/>
+            <a:r>
+              <a:rPr sz="1800" b="1">
+                <a:solidFill>
+                  <a:srgbClr val="1D1D1F"/>
+                </a:solidFill>
+                <a:latin typeface="Calibri"/>
+              </a:rPr>
+              <a:t>Run ads to sell the product. Don't put ads inside it.</a:t>
+            </a:r>
+          </a:p>
+        </p:txBody>
+      </p:sp>
+      <p:sp>
+        <p:nvSpPr>
+          <p:cNvPr id="7" name="Rounded Rectangle 6"/>
           <p:cNvSpPr/>
           <p:nvPr/>
         </p:nvSpPr>
         <p:spPr>
           <a:xfrm>
-            <a:off x="1025499" y="3383280"/>
-            <a:ext cx="3246120" cy="2011680"/>
+            <a:off x="1025499" y="3474720"/>
+            <a:ext cx="3246120" cy="1874519"/>
           </a:xfrm>
           <a:prstGeom prst="roundRect">
             <a:avLst/>
@@ -7825,13 +7875,13 @@
       </p:sp>
       <p:sp>
         <p:nvSpPr>
-          <p:cNvPr id="7" name="TextBox 6"/>
+          <p:cNvPr id="8" name="TextBox 7"/>
           <p:cNvSpPr txBox="1"/>
           <p:nvPr/>
         </p:nvSpPr>
         <p:spPr>
           <a:xfrm>
-            <a:off x="1162659" y="3639312"/>
+            <a:off x="1162659" y="3730752"/>
             <a:ext cx="2971800" cy="411480"/>
           </a:xfrm>
           <a:prstGeom prst="rect">
@@ -7860,13 +7910,13 @@
       </p:sp>
       <p:sp>
         <p:nvSpPr>
-          <p:cNvPr id="8" name="TextBox 7"/>
+          <p:cNvPr id="9" name="TextBox 8"/>
           <p:cNvSpPr txBox="1"/>
           <p:nvPr/>
         </p:nvSpPr>
         <p:spPr>
           <a:xfrm>
-            <a:off x="1190091" y="4160520"/>
+            <a:off x="1190091" y="4251959"/>
             <a:ext cx="2916936" cy="1143000"/>
           </a:xfrm>
           <a:prstGeom prst="rect">
@@ -7895,14 +7945,14 @@
       </p:sp>
       <p:sp>
         <p:nvSpPr>
-          <p:cNvPr id="9" name="Rounded Rectangle 8"/>
+          <p:cNvPr id="10" name="Rounded Rectangle 9"/>
           <p:cNvSpPr/>
           <p:nvPr/>
         </p:nvSpPr>
         <p:spPr>
           <a:xfrm>
-            <a:off x="4472787" y="3383280"/>
-            <a:ext cx="3246120" cy="2011680"/>
+            <a:off x="4472787" y="3474720"/>
+            <a:ext cx="3246120" cy="1874519"/>
           </a:xfrm>
           <a:prstGeom prst="roundRect">
             <a:avLst/>
@@ -7938,13 +7988,13 @@
       </p:sp>
       <p:sp>
         <p:nvSpPr>
-          <p:cNvPr id="10" name="TextBox 9"/>
+          <p:cNvPr id="11" name="TextBox 10"/>
           <p:cNvSpPr txBox="1"/>
           <p:nvPr/>
         </p:nvSpPr>
         <p:spPr>
           <a:xfrm>
-            <a:off x="4609947" y="3639312"/>
+            <a:off x="4609947" y="3730752"/>
             <a:ext cx="2971800" cy="411480"/>
           </a:xfrm>
           <a:prstGeom prst="rect">
@@ -7973,13 +8023,13 @@
       </p:sp>
       <p:sp>
         <p:nvSpPr>
-          <p:cNvPr id="11" name="TextBox 10"/>
+          <p:cNvPr id="12" name="TextBox 11"/>
           <p:cNvSpPr txBox="1"/>
           <p:nvPr/>
         </p:nvSpPr>
         <p:spPr>
           <a:xfrm>
-            <a:off x="4637379" y="4160520"/>
+            <a:off x="4637379" y="4251959"/>
             <a:ext cx="2916936" cy="1143000"/>
           </a:xfrm>
           <a:prstGeom prst="rect">
@@ -8008,14 +8058,14 @@
       </p:sp>
       <p:sp>
         <p:nvSpPr>
-          <p:cNvPr id="12" name="Rounded Rectangle 11"/>
+          <p:cNvPr id="13" name="Rounded Rectangle 12"/>
           <p:cNvSpPr/>
           <p:nvPr/>
         </p:nvSpPr>
         <p:spPr>
           <a:xfrm>
-            <a:off x="7920075" y="3383280"/>
-            <a:ext cx="3246120" cy="2011680"/>
+            <a:off x="7920075" y="3474720"/>
+            <a:ext cx="3246120" cy="1874519"/>
           </a:xfrm>
           <a:prstGeom prst="roundRect">
             <a:avLst/>
@@ -8051,13 +8101,13 @@
       </p:sp>
       <p:sp>
         <p:nvSpPr>
-          <p:cNvPr id="13" name="TextBox 12"/>
+          <p:cNvPr id="14" name="TextBox 13"/>
           <p:cNvSpPr txBox="1"/>
           <p:nvPr/>
         </p:nvSpPr>
         <p:spPr>
           <a:xfrm>
-            <a:off x="8057235" y="3639312"/>
+            <a:off x="8057235" y="3730752"/>
             <a:ext cx="2971800" cy="411480"/>
           </a:xfrm>
           <a:prstGeom prst="rect">
@@ -8086,13 +8136,13 @@
       </p:sp>
       <p:sp>
         <p:nvSpPr>
-          <p:cNvPr id="14" name="TextBox 13"/>
+          <p:cNvPr id="15" name="TextBox 14"/>
           <p:cNvSpPr txBox="1"/>
           <p:nvPr/>
         </p:nvSpPr>
         <p:spPr>
           <a:xfrm>
-            <a:off x="8084667" y="4160520"/>
+            <a:off x="8084667" y="4251959"/>
             <a:ext cx="2916936" cy="1143000"/>
           </a:xfrm>
           <a:prstGeom prst="rect">
@@ -11621,16 +11671,40 @@
           </a:p>
         </p:txBody>
       </p:sp>
-      <p:sp>
-        <p:nvSpPr>
-          <p:cNvPr id="3" name="TextBox 2"/>
+      <p:pic>
+        <p:nvPicPr>
+          <p:cNvPr id="3" name="Picture 2" descr="shipaton-prize-pool.png"/>
+          <p:cNvPicPr>
+            <a:picLocks noChangeAspect="1"/>
+          </p:cNvPicPr>
+          <p:nvPr/>
+        </p:nvPicPr>
+        <p:blipFill>
+          <a:blip r:embed="rId2"/>
+          <a:stretch>
+            <a:fillRect/>
+          </a:stretch>
+        </p:blipFill>
+        <p:spPr>
+          <a:xfrm>
+            <a:off x="320040" y="411480"/>
+            <a:ext cx="6035040" cy="6035040"/>
+          </a:xfrm>
+          <a:prstGeom prst="rect">
+            <a:avLst/>
+          </a:prstGeom>
+        </p:spPr>
+      </p:pic>
+      <p:sp>
+        <p:nvSpPr>
+          <p:cNvPr id="4" name="TextBox 3"/>
           <p:cNvSpPr txBox="1"/>
           <p:nvPr/>
         </p:nvSpPr>
         <p:spPr>
           <a:xfrm>
-            <a:off x="1097280" y="1874519"/>
-            <a:ext cx="9966960" cy="2377440"/>
+            <a:off x="6537960" y="1051560"/>
+            <a:ext cx="5212080" cy="2148840"/>
           </a:xfrm>
           <a:prstGeom prst="rect">
             <a:avLst/>
@@ -11643,9 +11717,9 @@
           </a:bodyPr>
           <a:lstStyle/>
           <a:p>
-            <a:pPr algn="ctr"/>
-            <a:r>
-              <a:rPr sz="2800" b="1">
+            <a:pPr algn="l"/>
+            <a:r>
+              <a:rPr sz="2200" b="1">
                 <a:solidFill>
                   <a:srgbClr val="F5F5F7"/>
                 </a:solidFill>
@@ -11658,14 +11732,14 @@
       </p:sp>
       <p:sp>
         <p:nvSpPr>
-          <p:cNvPr id="4" name="TextBox 3"/>
+          <p:cNvPr id="5" name="TextBox 4"/>
           <p:cNvSpPr txBox="1"/>
           <p:nvPr/>
         </p:nvSpPr>
         <p:spPr>
           <a:xfrm>
-            <a:off x="1097280" y="4434840"/>
-            <a:ext cx="9966960" cy="411480"/>
+            <a:off x="6537960" y="3246120"/>
+            <a:ext cx="5212080" cy="365760"/>
           </a:xfrm>
           <a:prstGeom prst="rect">
             <a:avLst/>
@@ -11678,7 +11752,7 @@
           </a:bodyPr>
           <a:lstStyle/>
           <a:p>
-            <a:pPr algn="ctr"/>
+            <a:pPr algn="l"/>
             <a:r>
               <a:rPr sz="1400" b="1">
                 <a:solidFill>
@@ -11687,6 +11761,41 @@
                 <a:latin typeface="Calibri"/>
               </a:rPr>
               <a:t>Steve Jobs</a:t>
+            </a:r>
+          </a:p>
+        </p:txBody>
+      </p:sp>
+      <p:sp>
+        <p:nvSpPr>
+          <p:cNvPr id="6" name="TextBox 5"/>
+          <p:cNvSpPr txBox="1"/>
+          <p:nvPr/>
+        </p:nvSpPr>
+        <p:spPr>
+          <a:xfrm>
+            <a:off x="6537960" y="3794760"/>
+            <a:ext cx="5212080" cy="2103120"/>
+          </a:xfrm>
+          <a:prstGeom prst="rect">
+            <a:avLst/>
+          </a:prstGeom>
+          <a:noFill/>
+        </p:spPr>
+        <p:txBody>
+          <a:bodyPr wrap="square">
+            <a:spAutoFit/>
+          </a:bodyPr>
+          <a:lstStyle/>
+          <a:p>
+            <a:pPr algn="l"/>
+            <a:r>
+              <a:rPr sz="1600" b="1">
+                <a:solidFill>
+                  <a:srgbClr val="F5F5F7"/>
+                </a:solidFill>
+                <a:latin typeface="Calibri"/>
+              </a:rPr>
+              <a:t>Today's prize pool is this. Nothing else is stopping you from a $1 billion company very soon. Think of the next $1 billion as your next hackathon-winning prize.</a:t>
             </a:r>
           </a:p>
         </p:txBody>

</xml_diff>